<commit_message>
docs(presentaciones): unificar sustentacion final en una sola presentacion con cifras verificadas y depurar APF2 redundante
</commit_message>
<xml_diff>
--- a/docs/gestion_academica/presentaciones/APF3_LEOFIT_Presentacion.pptx
+++ b/docs/gestion_academica/presentaciones/APF3_LEOFIT_Presentacion.pptx
@@ -24,9 +24,18 @@
     <p:sldId id="272" r:id="rId18"/>
     <p:sldId id="273" r:id="rId19"/>
     <p:sldId id="274" r:id="rId20"/>
+    <p:sldId id="275" r:id="rId21"/>
+    <p:sldId id="276" r:id="rId22"/>
+    <p:sldId id="277" r:id="rId23"/>
+    <p:sldId id="278" r:id="rId24"/>
+    <p:sldId id="279" r:id="rId25"/>
+    <p:sldId id="280" r:id="rId26"/>
+    <p:sldId id="281" r:id="rId27"/>
+    <p:sldId id="282" r:id="rId28"/>
+    <p:sldId id="283" r:id="rId29"/>
   </p:sldIdLst>
   <p:notesMasterIdLst>
-    <p:notesMasterId r:id="rId21"/>
+    <p:notesMasterId r:id="rId30"/>
   </p:notesMasterIdLst>
   <p:sldSz cx="12192000" cy="6858000"/>
   <p:notesSz cx="6858000" cy="12192000"/>
@@ -521,8 +530,8 @@
             <a:r>
               <a:rPr lang="en-US" dirty="0"/>
               <a:t>Expositor: Lady Luz Loayza Rodriguez (Scrum Master)
-Tiempo: 45 seg
-Guion: Estimado docente y miembros del jurado evaluador, tengan ustedes muy buenas tardes. Damos inicio a la sustentación del Avance de Proyecto Final 3 de nuestro proyecto: el Sistema Web PWA de Gestión y Toma de Pedidos Multicanal para la empresa LeoFit. Cumpliendo rigurosamente las pautas de la rúbrica oficial de 20 puntos, iniciamos formalmente con el levantamiento del 100% de las observaciones del APF2. A lo largo de esta sustentación demostraremos la calidad funcional automatizada, las pruebas de interoperabilidad con servicios externos, la evaluación formal de usabilidad bajo el estándar ISO/IEC 25010 y el despliegue productivo de la Versión 2 en la nube.</a:t>
+Tiempo: 40 seg
+Guion: Muy buenas tardes, estimado docente y miembros del jurado. Presentamos LeoFit, un sistema web progresivo para la gestión de pedidos de una microempresa de Gamarra. Hoy recorreremos el proyecto completo: el problema que resolvimos, la arquitectura, cómo garantizamos su calidad, su interoperabilidad con servicios externos, su usabilidad medida bajo ISO 25010 y, finalmente, el sistema funcionando en la nube.</a:t>
             </a:r>
             <a:endParaRPr lang="en-US" dirty="0"/>
           </a:p>
@@ -610,9 +619,9 @@
           <a:p>
             <a:r>
               <a:rPr lang="en-US" dirty="0"/>
-              <a:t>Expositor: Jim Alessandro Dávila Morales (QA / DevOps Lead)
-Tiempo: 10 seg
-Guion: Damos inicio al Bloque 4 para defender el Criterio 3 de la rúbrica, sustentando la evaluación formal de usabilidad bajo el estándar ISO/IEC 25010.</a:t>
+              <a:t>Expositor: Lady Luz Loayza Rodriguez (Scrum Master / DevSecOps)
+Tiempo: 40 seg
+Guion: Desde el avance anterior cerramos las brechas: pruebas automáticas de interoperabilidad, evaluación formal de usabilidad, trazabilidad entre historias de usuario y pruebas, y una segunda versión desplegada con pipelines automáticos. Jim Dávila presenta ahora la calidad funcional.</a:t>
             </a:r>
             <a:endParaRPr lang="en-US" dirty="0"/>
           </a:p>
@@ -700,9 +709,7 @@
           <a:p>
             <a:r>
               <a:rPr lang="en-US" dirty="0"/>
-              <a:t>Expositor: Jim Alessandro Dávila Morales (QA / DevOps Lead)
-Tiempo: 50 seg
-Guion: Estimado jurado calificador, el Criterio 3 exige evaluar la usabilidad con base en los subatributos de la norma ISO/IEC 25010. Analizamos cuatro pilares: facilidad de aprendizaje, donde el usuario completa la orden intuitivamente; protección contra errores, impidiendo que el cliente ingrese DNIs incompletos o reserve tallas agotadas; asistencia al usuario, proporcionando códigos unívocos de tracking; y compromiso visual mediante microinteracciones fluidas y estética profesional.</a:t>
+              <a:t/>
             </a:r>
             <a:endParaRPr lang="en-US" dirty="0"/>
           </a:p>
@@ -790,9 +797,9 @@
           <a:p>
             <a:r>
               <a:rPr lang="en-US" dirty="0"/>
-              <a:t>Expositor: Jim Alessandro Dávila Morales (QA / DevOps Lead)
-Tiempo: 45 seg
-Guion: Automatizamos estas validaciones en Vitest con nueve casos de prueba en usability_iso25010.test.ts. Verificamos que ningún producto carezca de precio, que los cupones no superen el 50% para proteger el margen de la microempresa, y que los estados del pedido sigan un flujo finito sin saltos inconsistentes. Todas las pruebas se ejecutaron en menos de 15 milisegundos con aprobación unánime.</a:t>
+              <a:t>Expositor: Jim Alessandro Dávila Morales (QA Lead / Backend)
+Tiempo: 50 seg
+Guion: El backend tiene diez suites. La más extensa cubre el ciclo de vida del pedido, con 13 casos. Hay pruebas de autenticación, de integración externa, de webhooks firmados, de seguridad y de contrato de la API. Usamos Jest con Supertest para ejercitar la API real sin mocks de la capa HTTP.</a:t>
             </a:r>
             <a:endParaRPr lang="en-US" dirty="0"/>
           </a:p>
@@ -880,9 +887,9 @@
           <a:p>
             <a:r>
               <a:rPr lang="en-US" dirty="0"/>
-              <a:t>Expositor: Jim Alessandro Dávila Morales (QA / DevOps Lead)
-Tiempo: 50 seg
-Guion: Los resultados cuantitativos demuestran la excelencia de la solución. Aplicamos el cuestionario internacional SUS obteniendo una calificación de 88.5 sobre 100, equivalente a Grado A excelente. La auditoría de Lighthouse otorgó 96 sobre 100 en accesibilidad móvil. En pruebas con usuarios reales registramos una tasa de éxito del 98.4% y un tiempo medio de toma de pedido de solo 38.2 segundos, superando con creces la meta contractual de dos minutos establecida en el pliego de requerimientos. Doy el pase a Daniel Rojas para sustentar el despliegue de la Versión 2 y el cierre del proyecto.</a:t>
+              <a:t>Expositor: Jim Alessandro Dávila Morales (QA Lead / Backend)
+Tiempo: 45 seg
+Guion: En total ejecutamos 101 pruebas aprobadas: 47 en backend y 54 en frontend, sin fallos. Hay una prueba de integración condicionada a una base de datos real que se omite en el entorno local. La cobertura de líneas en lógica de negocio es del 76% y llega al 100% en rutas, validadores y criptografía, que es donde está el mayor riesgo.</a:t>
             </a:r>
             <a:endParaRPr lang="en-US" dirty="0"/>
           </a:p>
@@ -970,9 +977,9 @@
           <a:p>
             <a:r>
               <a:rPr lang="en-US" dirty="0"/>
-              <a:t>Expositor: Daniel Enrique Rojas Sanchez (Analista de Negocio)
-Tiempo: 10 seg
-Guion: En el Bloque 5 culminamos con el despliegue productivo de la Versión 2, la trazabilidad en GitHub y la sustentación final.</a:t>
+              <a:t>Expositor: Jim Alessandro Dávila Morales (QA Lead / Backend)
+Tiempo: 30 seg
+Guion: Este gráfico muestra la cobertura módulo por módulo. Priorizamos los componentes críticos: autenticación, validación de contratos y criptografía de webhooks.</a:t>
             </a:r>
             <a:endParaRPr lang="en-US" dirty="0"/>
           </a:p>
@@ -1060,9 +1067,9 @@
           <a:p>
             <a:r>
               <a:rPr lang="en-US" dirty="0"/>
-              <a:t>Expositor: Daniel Enrique Rojas Sanchez (Analista de Negocio)
-Tiempo: 45 seg
-Guion: Estimado jurado, en el Criterio 4 presentamos la arquitectura desplegada de la Versión 2 del sistema. El frontend estático opera sobre la red Edge CDN de GitHub Pages garantizando alta velocidad de carga. Todas las peticiones transaccionales se dirigen a nuestro contenedor Docker alojado en Render, comunicándose bajo protocolo HTTPS seguro con certificados TLS 1.3 y conexión cifrada hacia la base de datos PostgreSQL.</a:t>
+              <a:t>Expositor: Jim Alessandro Dávila Morales (QA Lead / Backend)
+Tiempo: 35 seg
+Guion: Cada push a main dispara la publicación de la PWA: instalación, compilación y despliegue a la rama gh-pages. En paralelo, otros dos workflows ejecutan las pruebas del backend y el escaneo de seguridad, de modo que una regresión se detecta antes de llegar a producción. Doy la palabra a Harley Roman para la interoperabilidad.</a:t>
             </a:r>
             <a:endParaRPr lang="en-US" dirty="0"/>
           </a:p>
@@ -1150,9 +1157,7 @@
           <a:p>
             <a:r>
               <a:rPr lang="en-US" dirty="0"/>
-              <a:t>Expositor: Daniel Enrique Rojas Sanchez (Analista de Negocio)
-Tiempo: 50 seg
-Guion: En esta diapositiva validamos el funcionamiento real de la Versión 2 en la nube. Como pueden comprobar en la URL de producción, el sistema responde de forma instantánea. El endpoint de salud en Render confirma que la base de datos relacional se encuentra enlazada y operativa. En el panel administrativo podemos alternar el modo de privacidad financiera y verificar el historial de estados de cada pedido, corroborando que la solución no es un prototipo local sino un sistema productivo completamente terminado.</a:t>
+              <a:t/>
             </a:r>
             <a:endParaRPr lang="en-US" dirty="0"/>
           </a:p>
@@ -1240,9 +1245,9 @@
           <a:p>
             <a:r>
               <a:rPr lang="en-US" dirty="0"/>
-              <a:t>Expositor: Daniel Enrique Rojas Sanchez (Analista de Negocio)
-Tiempo: 45 seg
-Guion: El Artefacto 6 de la rúbrica exige evidenciar el historial progresivo de commits en GitHub. Nuestro repositorio refleja el trabajo continuo a lo largo del semestre mediante ramas estructuradas de trabajo y mensajes bajo el estándar Conventional Commits. Cada cambio fue integrado mediante Pull Requests revisados y validados por el pipeline automatizado de GitHub Actions, garantizando una trazabilidad técnica absoluta.</a:t>
+              <a:t>Expositor: Harley Anthony Roman Delgado (Frontend Lead / PWA)
+Tiempo: 50 seg
+Guion: El sistema se integra con WhatsApp para confirmar el pedido con su enlace de seguimiento, recibe confirmaciones de pago por webhook firmado y valida DNI y RUC. También emite rótulos con QR para las agencias de transporte. Con transparencia: los proveedores externos se consumen hoy mediante contratos simulados, diseñados para sustituirse por las APIs reales sin cambiar el núcleo.</a:t>
             </a:r>
             <a:endParaRPr lang="en-US" dirty="0"/>
           </a:p>
@@ -1330,9 +1335,9 @@
           <a:p>
             <a:r>
               <a:rPr lang="en-US" dirty="0"/>
-              <a:t>Expositor: Daniel Enrique Rojas Sanchez (Analista de Negocio)
-Tiempo: 45 seg
-Guion: En el Criterio 6 de sustentación resumimos los aportes individuales de cada integrante. Lady lideró la subsanación del APF2; Víctor construyó la suite funcional con más del 91% de cobertura; Harley desarrolló la interoperabilidad externa; Jim automatizó las pruebas de usabilidad ISO 25010 alcanzando 88.5 en el índice SUS; y quien les habla condujo la verificación de la Versión 2 en la nube y el cierre formal de la auditoría.</a:t>
+              <a:t>Expositor: Harley Anthony Roman Delgado (Frontend Lead / PWA)
+Tiempo: 40 seg
+Guion: Siete escenarios automatizados cubren los tres sistemas externos, incluyendo los casos negativos: teléfonos inválidos, proveedores no homologados y documentos malformados. Todos aprueban. Ahora presento la evaluación de usabilidad.</a:t>
             </a:r>
             <a:endParaRPr lang="en-US" dirty="0"/>
           </a:p>
@@ -1420,9 +1425,7 @@
           <a:p>
             <a:r>
               <a:rPr lang="en-US" dirty="0"/>
-              <a:t>Expositor: Daniel Enrique Rojas Sanchez (Analista de Negocio)
-Tiempo: 20 seg
-Guion: Con esto concluimos nuestra sustentación de la Entrega Final APF3. Hemos demostrado el cumplimiento integral de los criterios de la rúbrica con evidencia técnica sólida en código, pruebas y entorno productivo. Agradecemos su atención y quedamos a su entera disposición para responder a las preguntas del honorable jurado calificador.</a:t>
+              <a:t/>
             </a:r>
             <a:endParaRPr lang="en-US" dirty="0"/>
           </a:p>
@@ -1510,9 +1513,7 @@
           <a:p>
             <a:r>
               <a:rPr lang="en-US" dirty="0"/>
-              <a:t>Expositor: Lady Luz Loayza Rodriguez (Scrum Master)
-Tiempo: 10 seg
-Guion: Conforme exige la consigna de sustentación, iniciamos con la exposición del levantamiento integral de observaciones formuladas en el APF2.</a:t>
+              <a:t/>
             </a:r>
             <a:endParaRPr lang="en-US" dirty="0"/>
           </a:p>
@@ -1554,6 +1555,814 @@
 </p:notes>
 </file>
 
+<file path=ppt/notesSlides/notesSlide20.xml><?xml version="1.0" encoding="utf-8"?>
+<p:notes xmlns:a="http://schemas.openxmlformats.org/drawingml/2006/main" xmlns:r="http://schemas.openxmlformats.org/officeDocument/2006/relationships" xmlns:p="http://schemas.openxmlformats.org/presentationml/2006/main">
+  <p:cSld>
+    <p:spTree>
+      <p:nvGrpSpPr>
+        <p:cNvPr id="1" name=""/>
+        <p:cNvGrpSpPr/>
+        <p:nvPr/>
+      </p:nvGrpSpPr>
+      <p:grpSpPr>
+        <a:xfrm>
+          <a:off x="0" y="0"/>
+          <a:ext cx="0" cy="0"/>
+          <a:chOff x="0" y="0"/>
+          <a:chExt cx="0" cy="0"/>
+        </a:xfrm>
+      </p:grpSpPr>
+      <p:sp>
+        <p:nvSpPr>
+          <p:cNvPr id="2" name="Slide Image Placeholder 1"/>
+          <p:cNvSpPr>
+            <a:spLocks noGrp="1" noRot="1" noChangeAspect="1"/>
+          </p:cNvSpPr>
+          <p:nvPr>
+            <p:ph type="sldImg"/>
+          </p:nvPr>
+        </p:nvSpPr>
+        <p:spPr/>
+      </p:sp>
+      <p:sp>
+        <p:nvSpPr>
+          <p:cNvPr id="3" name="Notes Placeholder 2"/>
+          <p:cNvSpPr>
+            <a:spLocks noGrp="1"/>
+          </p:cNvSpPr>
+          <p:nvPr>
+            <p:ph type="body" idx="1"/>
+          </p:nvPr>
+        </p:nvSpPr>
+        <p:spPr/>
+        <p:txBody>
+          <a:bodyPr/>
+          <a:lstStyle/>
+          <a:p>
+            <a:r>
+              <a:rPr lang="en-US" dirty="0"/>
+              <a:t>Expositor: Harley Anthony Roman Delgado (Frontend Lead / PWA)
+Tiempo: 45 seg
+Guion: Evaluamos cuatro subatributos de la norma. El usuario aprende con un flujo guiado; el sistema le impide errores como reservar stock inexistente o ingresar un DNI incompleto; recibe un código de seguimiento y un resumen; y la interfaz responde con micro-interacciones. Nueve pruebas automatizadas verifican estas reglas.</a:t>
+            </a:r>
+            <a:endParaRPr lang="en-US" dirty="0"/>
+          </a:p>
+        </p:txBody>
+      </p:sp>
+      <p:sp>
+        <p:nvSpPr>
+          <p:cNvPr id="4" name="Slide Number Placeholder 3"/>
+          <p:cNvSpPr>
+            <a:spLocks noGrp="1"/>
+          </p:cNvSpPr>
+          <p:nvPr>
+            <p:ph type="sldNum" sz="quarter" idx="10"/>
+          </p:nvPr>
+        </p:nvSpPr>
+        <p:spPr/>
+        <p:txBody>
+          <a:bodyPr/>
+          <a:lstStyle/>
+          <a:p>
+            <a:fld id="{F7021451-1387-4CA6-816F-3879F97B5CBC}" type="slidenum">
+              <a:rPr lang="en-US"/>
+              <a:t>20</a:t>
+            </a:fld>
+            <a:endParaRPr lang="en-US"/>
+          </a:p>
+        </p:txBody>
+      </p:sp>
+    </p:spTree>
+    <p:extLst>
+      <p:ext uri="{BB962C8B-B14F-4D97-AF65-F5344CB8AC3E}">
+        <p14:creationId xmlns:p14="http://schemas.microsoft.com/office/powerpoint/2010/main" val="1024086991"/>
+      </p:ext>
+    </p:extLst>
+  </p:cSld>
+  <p:clrMapOvr>
+    <a:masterClrMapping/>
+  </p:clrMapOvr>
+</p:notes>
+</file>
+
+<file path=ppt/notesSlides/notesSlide21.xml><?xml version="1.0" encoding="utf-8"?>
+<p:notes xmlns:a="http://schemas.openxmlformats.org/drawingml/2006/main" xmlns:r="http://schemas.openxmlformats.org/officeDocument/2006/relationships" xmlns:p="http://schemas.openxmlformats.org/presentationml/2006/main">
+  <p:cSld>
+    <p:spTree>
+      <p:nvGrpSpPr>
+        <p:cNvPr id="1" name=""/>
+        <p:cNvGrpSpPr/>
+        <p:nvPr/>
+      </p:nvGrpSpPr>
+      <p:grpSpPr>
+        <a:xfrm>
+          <a:off x="0" y="0"/>
+          <a:ext cx="0" cy="0"/>
+          <a:chOff x="0" y="0"/>
+          <a:chExt cx="0" cy="0"/>
+        </a:xfrm>
+      </p:grpSpPr>
+      <p:sp>
+        <p:nvSpPr>
+          <p:cNvPr id="2" name="Slide Image Placeholder 1"/>
+          <p:cNvSpPr>
+            <a:spLocks noGrp="1" noRot="1" noChangeAspect="1"/>
+          </p:cNvSpPr>
+          <p:nvPr>
+            <p:ph type="sldImg"/>
+          </p:nvPr>
+        </p:nvSpPr>
+        <p:spPr/>
+      </p:sp>
+      <p:sp>
+        <p:nvSpPr>
+          <p:cNvPr id="3" name="Notes Placeholder 2"/>
+          <p:cNvSpPr>
+            <a:spLocks noGrp="1"/>
+          </p:cNvSpPr>
+          <p:nvPr>
+            <p:ph type="body" idx="1"/>
+          </p:nvPr>
+        </p:nvSpPr>
+        <p:spPr/>
+        <p:txBody>
+          <a:bodyPr/>
+          <a:lstStyle/>
+          <a:p>
+            <a:r>
+              <a:rPr lang="en-US" dirty="0"/>
+              <a:t>Expositor: Harley Anthony Roman Delgado (Frontend Lead / PWA)
+Tiempo: 50 seg
+Guion: En el estudio de campo con diez usuarios, el cuestionario SUS arrojó 88.5 sobre 100. El tiempo de captura de un pedido bajó de 45 minutos a 38 segundos y los errores operativos a 0.4%. En rendimiento web, el LCP es de 1.4 segundos y el CLS de 0.01. Doy la palabra a Daniel Rojas para la nube y el repositorio.</a:t>
+            </a:r>
+            <a:endParaRPr lang="en-US" dirty="0"/>
+          </a:p>
+        </p:txBody>
+      </p:sp>
+      <p:sp>
+        <p:nvSpPr>
+          <p:cNvPr id="4" name="Slide Number Placeholder 3"/>
+          <p:cNvSpPr>
+            <a:spLocks noGrp="1"/>
+          </p:cNvSpPr>
+          <p:nvPr>
+            <p:ph type="sldNum" sz="quarter" idx="10"/>
+          </p:nvPr>
+        </p:nvSpPr>
+        <p:spPr/>
+        <p:txBody>
+          <a:bodyPr/>
+          <a:lstStyle/>
+          <a:p>
+            <a:fld id="{F7021451-1387-4CA6-816F-3879F97B5CBC}" type="slidenum">
+              <a:rPr lang="en-US"/>
+              <a:t>21</a:t>
+            </a:fld>
+            <a:endParaRPr lang="en-US"/>
+          </a:p>
+        </p:txBody>
+      </p:sp>
+    </p:spTree>
+    <p:extLst>
+      <p:ext uri="{BB962C8B-B14F-4D97-AF65-F5344CB8AC3E}">
+        <p14:creationId xmlns:p14="http://schemas.microsoft.com/office/powerpoint/2010/main" val="1024086991"/>
+      </p:ext>
+    </p:extLst>
+  </p:cSld>
+  <p:clrMapOvr>
+    <a:masterClrMapping/>
+  </p:clrMapOvr>
+</p:notes>
+</file>
+
+<file path=ppt/notesSlides/notesSlide22.xml><?xml version="1.0" encoding="utf-8"?>
+<p:notes xmlns:a="http://schemas.openxmlformats.org/drawingml/2006/main" xmlns:r="http://schemas.openxmlformats.org/officeDocument/2006/relationships" xmlns:p="http://schemas.openxmlformats.org/presentationml/2006/main">
+  <p:cSld>
+    <p:spTree>
+      <p:nvGrpSpPr>
+        <p:cNvPr id="1" name=""/>
+        <p:cNvGrpSpPr/>
+        <p:nvPr/>
+      </p:nvGrpSpPr>
+      <p:grpSpPr>
+        <a:xfrm>
+          <a:off x="0" y="0"/>
+          <a:ext cx="0" cy="0"/>
+          <a:chOff x="0" y="0"/>
+          <a:chExt cx="0" cy="0"/>
+        </a:xfrm>
+      </p:grpSpPr>
+      <p:sp>
+        <p:nvSpPr>
+          <p:cNvPr id="2" name="Slide Image Placeholder 1"/>
+          <p:cNvSpPr>
+            <a:spLocks noGrp="1" noRot="1" noChangeAspect="1"/>
+          </p:cNvSpPr>
+          <p:nvPr>
+            <p:ph type="sldImg"/>
+          </p:nvPr>
+        </p:nvSpPr>
+        <p:spPr/>
+      </p:sp>
+      <p:sp>
+        <p:nvSpPr>
+          <p:cNvPr id="3" name="Notes Placeholder 2"/>
+          <p:cNvSpPr>
+            <a:spLocks noGrp="1"/>
+          </p:cNvSpPr>
+          <p:nvPr>
+            <p:ph type="body" idx="1"/>
+          </p:nvPr>
+        </p:nvSpPr>
+        <p:spPr/>
+        <p:txBody>
+          <a:bodyPr/>
+          <a:lstStyle/>
+          <a:p>
+            <a:r>
+              <a:rPr lang="en-US" dirty="0"/>
+              <a:t/>
+            </a:r>
+            <a:endParaRPr lang="en-US" dirty="0"/>
+          </a:p>
+        </p:txBody>
+      </p:sp>
+      <p:sp>
+        <p:nvSpPr>
+          <p:cNvPr id="4" name="Slide Number Placeholder 3"/>
+          <p:cNvSpPr>
+            <a:spLocks noGrp="1"/>
+          </p:cNvSpPr>
+          <p:nvPr>
+            <p:ph type="sldNum" sz="quarter" idx="10"/>
+          </p:nvPr>
+        </p:nvSpPr>
+        <p:spPr/>
+        <p:txBody>
+          <a:bodyPr/>
+          <a:lstStyle/>
+          <a:p>
+            <a:fld id="{F7021451-1387-4CA6-816F-3879F97B5CBC}" type="slidenum">
+              <a:rPr lang="en-US"/>
+              <a:t>22</a:t>
+            </a:fld>
+            <a:endParaRPr lang="en-US"/>
+          </a:p>
+        </p:txBody>
+      </p:sp>
+    </p:spTree>
+    <p:extLst>
+      <p:ext uri="{BB962C8B-B14F-4D97-AF65-F5344CB8AC3E}">
+        <p14:creationId xmlns:p14="http://schemas.microsoft.com/office/powerpoint/2010/main" val="1024086991"/>
+      </p:ext>
+    </p:extLst>
+  </p:cSld>
+  <p:clrMapOvr>
+    <a:masterClrMapping/>
+  </p:clrMapOvr>
+</p:notes>
+</file>
+
+<file path=ppt/notesSlides/notesSlide23.xml><?xml version="1.0" encoding="utf-8"?>
+<p:notes xmlns:a="http://schemas.openxmlformats.org/drawingml/2006/main" xmlns:r="http://schemas.openxmlformats.org/officeDocument/2006/relationships" xmlns:p="http://schemas.openxmlformats.org/presentationml/2006/main">
+  <p:cSld>
+    <p:spTree>
+      <p:nvGrpSpPr>
+        <p:cNvPr id="1" name=""/>
+        <p:cNvGrpSpPr/>
+        <p:nvPr/>
+      </p:nvGrpSpPr>
+      <p:grpSpPr>
+        <a:xfrm>
+          <a:off x="0" y="0"/>
+          <a:ext cx="0" cy="0"/>
+          <a:chOff x="0" y="0"/>
+          <a:chExt cx="0" cy="0"/>
+        </a:xfrm>
+      </p:grpSpPr>
+      <p:sp>
+        <p:nvSpPr>
+          <p:cNvPr id="2" name="Slide Image Placeholder 1"/>
+          <p:cNvSpPr>
+            <a:spLocks noGrp="1" noRot="1" noChangeAspect="1"/>
+          </p:cNvSpPr>
+          <p:nvPr>
+            <p:ph type="sldImg"/>
+          </p:nvPr>
+        </p:nvSpPr>
+        <p:spPr/>
+      </p:sp>
+      <p:sp>
+        <p:nvSpPr>
+          <p:cNvPr id="3" name="Notes Placeholder 2"/>
+          <p:cNvSpPr>
+            <a:spLocks noGrp="1"/>
+          </p:cNvSpPr>
+          <p:nvPr>
+            <p:ph type="body" idx="1"/>
+          </p:nvPr>
+        </p:nvSpPr>
+        <p:spPr/>
+        <p:txBody>
+          <a:bodyPr/>
+          <a:lstStyle/>
+          <a:p>
+            <a:r>
+              <a:rPr lang="en-US" dirty="0"/>
+              <a:t>Expositor: Daniel Enrique Rojas Sanchez (Analista de Negocio / Cloud DevOps)
+Tiempo: 40 seg
+Guion: El frontend estático se sirve desde la CDN de GitHub Pages y la API con su base PostgreSQL corre en Render. La comunicación es por HTTPS. Reconocemos una limitación del plan gratuito: el primer request tras inactividad tiene arranque en frío.</a:t>
+            </a:r>
+            <a:endParaRPr lang="en-US" dirty="0"/>
+          </a:p>
+        </p:txBody>
+      </p:sp>
+      <p:sp>
+        <p:nvSpPr>
+          <p:cNvPr id="4" name="Slide Number Placeholder 3"/>
+          <p:cNvSpPr>
+            <a:spLocks noGrp="1"/>
+          </p:cNvSpPr>
+          <p:nvPr>
+            <p:ph type="sldNum" sz="quarter" idx="10"/>
+          </p:nvPr>
+        </p:nvSpPr>
+        <p:spPr/>
+        <p:txBody>
+          <a:bodyPr/>
+          <a:lstStyle/>
+          <a:p>
+            <a:fld id="{F7021451-1387-4CA6-816F-3879F97B5CBC}" type="slidenum">
+              <a:rPr lang="en-US"/>
+              <a:t>23</a:t>
+            </a:fld>
+            <a:endParaRPr lang="en-US"/>
+          </a:p>
+        </p:txBody>
+      </p:sp>
+    </p:spTree>
+    <p:extLst>
+      <p:ext uri="{BB962C8B-B14F-4D97-AF65-F5344CB8AC3E}">
+        <p14:creationId xmlns:p14="http://schemas.microsoft.com/office/powerpoint/2010/main" val="1024086991"/>
+      </p:ext>
+    </p:extLst>
+  </p:cSld>
+  <p:clrMapOvr>
+    <a:masterClrMapping/>
+  </p:clrMapOvr>
+</p:notes>
+</file>
+
+<file path=ppt/notesSlides/notesSlide24.xml><?xml version="1.0" encoding="utf-8"?>
+<p:notes xmlns:a="http://schemas.openxmlformats.org/drawingml/2006/main" xmlns:r="http://schemas.openxmlformats.org/officeDocument/2006/relationships" xmlns:p="http://schemas.openxmlformats.org/presentationml/2006/main">
+  <p:cSld>
+    <p:spTree>
+      <p:nvGrpSpPr>
+        <p:cNvPr id="1" name=""/>
+        <p:cNvGrpSpPr/>
+        <p:nvPr/>
+      </p:nvGrpSpPr>
+      <p:grpSpPr>
+        <a:xfrm>
+          <a:off x="0" y="0"/>
+          <a:ext cx="0" cy="0"/>
+          <a:chOff x="0" y="0"/>
+          <a:chExt cx="0" cy="0"/>
+        </a:xfrm>
+      </p:grpSpPr>
+      <p:sp>
+        <p:nvSpPr>
+          <p:cNvPr id="2" name="Slide Image Placeholder 1"/>
+          <p:cNvSpPr>
+            <a:spLocks noGrp="1" noRot="1" noChangeAspect="1"/>
+          </p:cNvSpPr>
+          <p:nvPr>
+            <p:ph type="sldImg"/>
+          </p:nvPr>
+        </p:nvSpPr>
+        <p:spPr/>
+      </p:sp>
+      <p:sp>
+        <p:nvSpPr>
+          <p:cNvPr id="3" name="Notes Placeholder 2"/>
+          <p:cNvSpPr>
+            <a:spLocks noGrp="1"/>
+          </p:cNvSpPr>
+          <p:nvPr>
+            <p:ph type="body" idx="1"/>
+          </p:nvPr>
+        </p:nvSpPr>
+        <p:spPr/>
+        <p:txBody>
+          <a:bodyPr/>
+          <a:lstStyle/>
+          <a:p>
+            <a:r>
+              <a:rPr lang="en-US" dirty="0"/>
+              <a:t>Expositor: Daniel Enrique Rojas Sanchez (Analista de Negocio / Cloud DevOps)
+Tiempo: 60 seg
+Guion: Pasamos a la demostración en vivo. Verificamos el endpoint de salud de la API, ingresamos como operador, creamos un pedido desde el catálogo y consultamos su estado en el portal público de seguimiento.</a:t>
+            </a:r>
+            <a:endParaRPr lang="en-US" dirty="0"/>
+          </a:p>
+        </p:txBody>
+      </p:sp>
+      <p:sp>
+        <p:nvSpPr>
+          <p:cNvPr id="4" name="Slide Number Placeholder 3"/>
+          <p:cNvSpPr>
+            <a:spLocks noGrp="1"/>
+          </p:cNvSpPr>
+          <p:nvPr>
+            <p:ph type="sldNum" sz="quarter" idx="10"/>
+          </p:nvPr>
+        </p:nvSpPr>
+        <p:spPr/>
+        <p:txBody>
+          <a:bodyPr/>
+          <a:lstStyle/>
+          <a:p>
+            <a:fld id="{F7021451-1387-4CA6-816F-3879F97B5CBC}" type="slidenum">
+              <a:rPr lang="en-US"/>
+              <a:t>24</a:t>
+            </a:fld>
+            <a:endParaRPr lang="en-US"/>
+          </a:p>
+        </p:txBody>
+      </p:sp>
+    </p:spTree>
+    <p:extLst>
+      <p:ext uri="{BB962C8B-B14F-4D97-AF65-F5344CB8AC3E}">
+        <p14:creationId xmlns:p14="http://schemas.microsoft.com/office/powerpoint/2010/main" val="1024086991"/>
+      </p:ext>
+    </p:extLst>
+  </p:cSld>
+  <p:clrMapOvr>
+    <a:masterClrMapping/>
+  </p:clrMapOvr>
+</p:notes>
+</file>
+
+<file path=ppt/notesSlides/notesSlide25.xml><?xml version="1.0" encoding="utf-8"?>
+<p:notes xmlns:a="http://schemas.openxmlformats.org/drawingml/2006/main" xmlns:r="http://schemas.openxmlformats.org/officeDocument/2006/relationships" xmlns:p="http://schemas.openxmlformats.org/presentationml/2006/main">
+  <p:cSld>
+    <p:spTree>
+      <p:nvGrpSpPr>
+        <p:cNvPr id="1" name=""/>
+        <p:cNvGrpSpPr/>
+        <p:nvPr/>
+      </p:nvGrpSpPr>
+      <p:grpSpPr>
+        <a:xfrm>
+          <a:off x="0" y="0"/>
+          <a:ext cx="0" cy="0"/>
+          <a:chOff x="0" y="0"/>
+          <a:chExt cx="0" cy="0"/>
+        </a:xfrm>
+      </p:grpSpPr>
+      <p:sp>
+        <p:nvSpPr>
+          <p:cNvPr id="2" name="Slide Image Placeholder 1"/>
+          <p:cNvSpPr>
+            <a:spLocks noGrp="1" noRot="1" noChangeAspect="1"/>
+          </p:cNvSpPr>
+          <p:nvPr>
+            <p:ph type="sldImg"/>
+          </p:nvPr>
+        </p:nvSpPr>
+        <p:spPr/>
+      </p:sp>
+      <p:sp>
+        <p:nvSpPr>
+          <p:cNvPr id="3" name="Notes Placeholder 2"/>
+          <p:cNvSpPr>
+            <a:spLocks noGrp="1"/>
+          </p:cNvSpPr>
+          <p:nvPr>
+            <p:ph type="body" idx="1"/>
+          </p:nvPr>
+        </p:nvSpPr>
+        <p:spPr/>
+        <p:txBody>
+          <a:bodyPr/>
+          <a:lstStyle/>
+          <a:p>
+            <a:r>
+              <a:rPr lang="en-US" dirty="0"/>
+              <a:t>Expositor: Daniel Enrique Rojas Sanchez (Analista de Negocio / Cloud DevOps)
+Tiempo: 35 seg
+Guion: El repositorio registra más de doscientos sesenta commits, con una rama de trabajo por integrante y mensajes bajo Conventional Commits. Los workflows de GitHub Actions ejecutan pruebas, despliegue y escaneo de seguridad.</a:t>
+            </a:r>
+            <a:endParaRPr lang="en-US" dirty="0"/>
+          </a:p>
+        </p:txBody>
+      </p:sp>
+      <p:sp>
+        <p:nvSpPr>
+          <p:cNvPr id="4" name="Slide Number Placeholder 3"/>
+          <p:cNvSpPr>
+            <a:spLocks noGrp="1"/>
+          </p:cNvSpPr>
+          <p:nvPr>
+            <p:ph type="sldNum" sz="quarter" idx="10"/>
+          </p:nvPr>
+        </p:nvSpPr>
+        <p:spPr/>
+        <p:txBody>
+          <a:bodyPr/>
+          <a:lstStyle/>
+          <a:p>
+            <a:fld id="{F7021451-1387-4CA6-816F-3879F97B5CBC}" type="slidenum">
+              <a:rPr lang="en-US"/>
+              <a:t>25</a:t>
+            </a:fld>
+            <a:endParaRPr lang="en-US"/>
+          </a:p>
+        </p:txBody>
+      </p:sp>
+    </p:spTree>
+    <p:extLst>
+      <p:ext uri="{BB962C8B-B14F-4D97-AF65-F5344CB8AC3E}">
+        <p14:creationId xmlns:p14="http://schemas.microsoft.com/office/powerpoint/2010/main" val="1024086991"/>
+      </p:ext>
+    </p:extLst>
+  </p:cSld>
+  <p:clrMapOvr>
+    <a:masterClrMapping/>
+  </p:clrMapOvr>
+</p:notes>
+</file>
+
+<file path=ppt/notesSlides/notesSlide26.xml><?xml version="1.0" encoding="utf-8"?>
+<p:notes xmlns:a="http://schemas.openxmlformats.org/drawingml/2006/main" xmlns:r="http://schemas.openxmlformats.org/officeDocument/2006/relationships" xmlns:p="http://schemas.openxmlformats.org/presentationml/2006/main">
+  <p:cSld>
+    <p:spTree>
+      <p:nvGrpSpPr>
+        <p:cNvPr id="1" name=""/>
+        <p:cNvGrpSpPr/>
+        <p:nvPr/>
+      </p:nvGrpSpPr>
+      <p:grpSpPr>
+        <a:xfrm>
+          <a:off x="0" y="0"/>
+          <a:ext cx="0" cy="0"/>
+          <a:chOff x="0" y="0"/>
+          <a:chExt cx="0" cy="0"/>
+        </a:xfrm>
+      </p:grpSpPr>
+      <p:sp>
+        <p:nvSpPr>
+          <p:cNvPr id="2" name="Slide Image Placeholder 1"/>
+          <p:cNvSpPr>
+            <a:spLocks noGrp="1" noRot="1" noChangeAspect="1"/>
+          </p:cNvSpPr>
+          <p:nvPr>
+            <p:ph type="sldImg"/>
+          </p:nvPr>
+        </p:nvSpPr>
+        <p:spPr/>
+      </p:sp>
+      <p:sp>
+        <p:nvSpPr>
+          <p:cNvPr id="3" name="Notes Placeholder 2"/>
+          <p:cNvSpPr>
+            <a:spLocks noGrp="1"/>
+          </p:cNvSpPr>
+          <p:nvPr>
+            <p:ph type="body" idx="1"/>
+          </p:nvPr>
+        </p:nvSpPr>
+        <p:spPr/>
+        <p:txBody>
+          <a:bodyPr/>
+          <a:lstStyle/>
+          <a:p>
+            <a:r>
+              <a:rPr lang="en-US" dirty="0"/>
+              <a:t>Expositor: Lady Luz Loayza Rodriguez (Scrum Master / DevSecOps)
+Tiempo: 30 seg
+Guion: Cada integrante lideró un frente técnico. Lady, la seguridad y la gestión del sprint; Víctor, el modelo de datos y las transacciones; Harley, la PWA y la interoperabilidad; Jim, la batería de pruebas; y Daniel, el análisis de negocio y el despliegue.</a:t>
+            </a:r>
+            <a:endParaRPr lang="en-US" dirty="0"/>
+          </a:p>
+        </p:txBody>
+      </p:sp>
+      <p:sp>
+        <p:nvSpPr>
+          <p:cNvPr id="4" name="Slide Number Placeholder 3"/>
+          <p:cNvSpPr>
+            <a:spLocks noGrp="1"/>
+          </p:cNvSpPr>
+          <p:nvPr>
+            <p:ph type="sldNum" sz="quarter" idx="10"/>
+          </p:nvPr>
+        </p:nvSpPr>
+        <p:spPr/>
+        <p:txBody>
+          <a:bodyPr/>
+          <a:lstStyle/>
+          <a:p>
+            <a:fld id="{F7021451-1387-4CA6-816F-3879F97B5CBC}" type="slidenum">
+              <a:rPr lang="en-US"/>
+              <a:t>26</a:t>
+            </a:fld>
+            <a:endParaRPr lang="en-US"/>
+          </a:p>
+        </p:txBody>
+      </p:sp>
+    </p:spTree>
+    <p:extLst>
+      <p:ext uri="{BB962C8B-B14F-4D97-AF65-F5344CB8AC3E}">
+        <p14:creationId xmlns:p14="http://schemas.microsoft.com/office/powerpoint/2010/main" val="1024086991"/>
+      </p:ext>
+    </p:extLst>
+  </p:cSld>
+  <p:clrMapOvr>
+    <a:masterClrMapping/>
+  </p:clrMapOvr>
+</p:notes>
+</file>
+
+<file path=ppt/notesSlides/notesSlide27.xml><?xml version="1.0" encoding="utf-8"?>
+<p:notes xmlns:a="http://schemas.openxmlformats.org/drawingml/2006/main" xmlns:r="http://schemas.openxmlformats.org/officeDocument/2006/relationships" xmlns:p="http://schemas.openxmlformats.org/presentationml/2006/main">
+  <p:cSld>
+    <p:spTree>
+      <p:nvGrpSpPr>
+        <p:cNvPr id="1" name=""/>
+        <p:cNvGrpSpPr/>
+        <p:nvPr/>
+      </p:nvGrpSpPr>
+      <p:grpSpPr>
+        <a:xfrm>
+          <a:off x="0" y="0"/>
+          <a:ext cx="0" cy="0"/>
+          <a:chOff x="0" y="0"/>
+          <a:chExt cx="0" cy="0"/>
+        </a:xfrm>
+      </p:grpSpPr>
+      <p:sp>
+        <p:nvSpPr>
+          <p:cNvPr id="2" name="Slide Image Placeholder 1"/>
+          <p:cNvSpPr>
+            <a:spLocks noGrp="1" noRot="1" noChangeAspect="1"/>
+          </p:cNvSpPr>
+          <p:nvPr>
+            <p:ph type="sldImg"/>
+          </p:nvPr>
+        </p:nvSpPr>
+        <p:spPr/>
+      </p:sp>
+      <p:sp>
+        <p:nvSpPr>
+          <p:cNvPr id="3" name="Notes Placeholder 2"/>
+          <p:cNvSpPr>
+            <a:spLocks noGrp="1"/>
+          </p:cNvSpPr>
+          <p:nvPr>
+            <p:ph type="body" idx="1"/>
+          </p:nvPr>
+        </p:nvSpPr>
+        <p:spPr/>
+        <p:txBody>
+          <a:bodyPr/>
+          <a:lstStyle/>
+          <a:p>
+            <a:r>
+              <a:rPr lang="en-US" dirty="0"/>
+              <a:t>Expositor: Lady Luz Loayza Rodriguez (Scrum Master / DevSecOps)
+Tiempo: 45 seg
+Guion: Como conclusión, LeoFit redujo el tiempo de pedido de 45 minutos a 38 segundos, mantiene el stock consistente bajo concurrencia y está respaldado por 101 pruebas automáticas. Reconocemos sus límites: el arranque en frío del plan gratuito, el modo offline basado en caché y los proveedores simulados. La hoja de ruta incluye un Service Worker con Workbox, una pasarela de pago directa y un contenedor dedicado.</a:t>
+            </a:r>
+            <a:endParaRPr lang="en-US" dirty="0"/>
+          </a:p>
+        </p:txBody>
+      </p:sp>
+      <p:sp>
+        <p:nvSpPr>
+          <p:cNvPr id="4" name="Slide Number Placeholder 3"/>
+          <p:cNvSpPr>
+            <a:spLocks noGrp="1"/>
+          </p:cNvSpPr>
+          <p:nvPr>
+            <p:ph type="sldNum" sz="quarter" idx="10"/>
+          </p:nvPr>
+        </p:nvSpPr>
+        <p:spPr/>
+        <p:txBody>
+          <a:bodyPr/>
+          <a:lstStyle/>
+          <a:p>
+            <a:fld id="{F7021451-1387-4CA6-816F-3879F97B5CBC}" type="slidenum">
+              <a:rPr lang="en-US"/>
+              <a:t>27</a:t>
+            </a:fld>
+            <a:endParaRPr lang="en-US"/>
+          </a:p>
+        </p:txBody>
+      </p:sp>
+    </p:spTree>
+    <p:extLst>
+      <p:ext uri="{BB962C8B-B14F-4D97-AF65-F5344CB8AC3E}">
+        <p14:creationId xmlns:p14="http://schemas.microsoft.com/office/powerpoint/2010/main" val="1024086991"/>
+      </p:ext>
+    </p:extLst>
+  </p:cSld>
+  <p:clrMapOvr>
+    <a:masterClrMapping/>
+  </p:clrMapOvr>
+</p:notes>
+</file>
+
+<file path=ppt/notesSlides/notesSlide28.xml><?xml version="1.0" encoding="utf-8"?>
+<p:notes xmlns:a="http://schemas.openxmlformats.org/drawingml/2006/main" xmlns:r="http://schemas.openxmlformats.org/officeDocument/2006/relationships" xmlns:p="http://schemas.openxmlformats.org/presentationml/2006/main">
+  <p:cSld>
+    <p:spTree>
+      <p:nvGrpSpPr>
+        <p:cNvPr id="1" name=""/>
+        <p:cNvGrpSpPr/>
+        <p:nvPr/>
+      </p:nvGrpSpPr>
+      <p:grpSpPr>
+        <a:xfrm>
+          <a:off x="0" y="0"/>
+          <a:ext cx="0" cy="0"/>
+          <a:chOff x="0" y="0"/>
+          <a:chExt cx="0" cy="0"/>
+        </a:xfrm>
+      </p:grpSpPr>
+      <p:sp>
+        <p:nvSpPr>
+          <p:cNvPr id="2" name="Slide Image Placeholder 1"/>
+          <p:cNvSpPr>
+            <a:spLocks noGrp="1" noRot="1" noChangeAspect="1"/>
+          </p:cNvSpPr>
+          <p:nvPr>
+            <p:ph type="sldImg"/>
+          </p:nvPr>
+        </p:nvSpPr>
+        <p:spPr/>
+      </p:sp>
+      <p:sp>
+        <p:nvSpPr>
+          <p:cNvPr id="3" name="Notes Placeholder 2"/>
+          <p:cNvSpPr>
+            <a:spLocks noGrp="1"/>
+          </p:cNvSpPr>
+          <p:nvPr>
+            <p:ph type="body" idx="1"/>
+          </p:nvPr>
+        </p:nvSpPr>
+        <p:spPr/>
+        <p:txBody>
+          <a:bodyPr/>
+          <a:lstStyle/>
+          <a:p>
+            <a:r>
+              <a:rPr lang="en-US" dirty="0"/>
+              <a:t>Expositor: Lady Luz Loayza Rodriguez (Scrum Master / DevSecOps)
+Tiempo: 15 seg
+Guion: Con esto concluimos nuestra sustentación. Agradecemos su atención y quedamos atentos a sus preguntas.</a:t>
+            </a:r>
+            <a:endParaRPr lang="en-US" dirty="0"/>
+          </a:p>
+        </p:txBody>
+      </p:sp>
+      <p:sp>
+        <p:nvSpPr>
+          <p:cNvPr id="4" name="Slide Number Placeholder 3"/>
+          <p:cNvSpPr>
+            <a:spLocks noGrp="1"/>
+          </p:cNvSpPr>
+          <p:nvPr>
+            <p:ph type="sldNum" sz="quarter" idx="10"/>
+          </p:nvPr>
+        </p:nvSpPr>
+        <p:spPr/>
+        <p:txBody>
+          <a:bodyPr/>
+          <a:lstStyle/>
+          <a:p>
+            <a:fld id="{F7021451-1387-4CA6-816F-3879F97B5CBC}" type="slidenum">
+              <a:rPr lang="en-US"/>
+              <a:t>28</a:t>
+            </a:fld>
+            <a:endParaRPr lang="en-US"/>
+          </a:p>
+        </p:txBody>
+      </p:sp>
+    </p:spTree>
+    <p:extLst>
+      <p:ext uri="{BB962C8B-B14F-4D97-AF65-F5344CB8AC3E}">
+        <p14:creationId xmlns:p14="http://schemas.microsoft.com/office/powerpoint/2010/main" val="1024086991"/>
+      </p:ext>
+    </p:extLst>
+  </p:cSld>
+  <p:clrMapOvr>
+    <a:masterClrMapping/>
+  </p:clrMapOvr>
+</p:notes>
+</file>
+
 <file path=ppt/notesSlides/notesSlide3.xml><?xml version="1.0" encoding="utf-8"?>
 <p:notes xmlns:a="http://schemas.openxmlformats.org/drawingml/2006/main" xmlns:r="http://schemas.openxmlformats.org/officeDocument/2006/relationships" xmlns:p="http://schemas.openxmlformats.org/presentationml/2006/main">
   <p:cSld>
@@ -1600,9 +2409,9 @@
           <a:p>
             <a:r>
               <a:rPr lang="en-US" dirty="0"/>
-              <a:t>Expositor: Lady Luz Loayza Rodriguez (Scrum Master)
+              <a:t>Expositor: Daniel Enrique Rojas Sanchez (Analista de Negocio)
 Tiempo: 55 seg
-Guion: En estricto apego al mandato de la rúbrica, exponemos la resolución del 100% de las observaciones previas. Implementamos la suite automatizada de integración para comunicación con WhatsApp, pasarela de pago y validación de padrones de identidad. Ejecutamos la auditoría de usabilidad bajo la norma ISO 25010 incorporando la escala SUS y mediciones de Lighthouse. Asimismo, sincronizamos la matriz de trazabilidad y actualizamos el manual de despliegue cloud para la Versión 2. Habiendo certificado el cumplimiento de este criterio, cedo la palabra a nuestro Product Owner, Víctor Cárdenas, para sustentar la arquitectura de pruebas funcionales automatizadas.</a:t>
+Guion: LeoFit atendía sus pedidos por chats y una libreta. Eso significaba entre 45 y 120 minutos por orden, 14.2% de errores en despacho y un 22% de intención de compra perdida porque el cliente no veía qué tallas quedaban. Con la PWA, la captura de un pedido toma 38 segundos y el error operativo bajó a 0.4%, medido en el estudio de campo con usuarios.</a:t>
             </a:r>
             <a:endParaRPr lang="en-US" dirty="0"/>
           </a:p>
@@ -1690,9 +2499,9 @@
           <a:p>
             <a:r>
               <a:rPr lang="en-US" dirty="0"/>
-              <a:t>Expositor: Víctor Leandro Cárdenas Fernández (Product Owner / Backend)
-Tiempo: 10 seg
-Guion: En el Bloque 2 defendemos el Criterio 1 de la rúbrica, demostrando la calidad funcional automatizada y los reportes de cobertura de código.</a:t>
+              <a:t>Expositor: Daniel Enrique Rojas Sanchez (Analista de Negocio)
+Tiempo: 40 seg
+Guion: Este es el proceso rediseñado. El pedido nace en la PWA, el stock se valida y descuenta de forma transaccional, el operador gestiona el despacho y el cliente consulta el estado por su código de seguimiento, sin intermediarios manuales. Cedo la palabra a Víctor Cárdenas para explicar la arquitectura.</a:t>
             </a:r>
             <a:endParaRPr lang="en-US" dirty="0"/>
           </a:p>
@@ -1780,9 +2589,7 @@
           <a:p>
             <a:r>
               <a:rPr lang="en-US" dirty="0"/>
-              <a:t>Expositor: Víctor Leandro Cárdenas Fernández (Product Owner / Backend)
-Tiempo: 50 seg
-Guion: Gracias, Lady. Saludos cordiales. En el Criterio 1 de la rúbrica evaluamos la calidad funcional bajo la norma ISO 25010 mediante pruebas automatizadas. Implementamos Jest, Supertest y Vitest en un entorno riguroso de integración continua. Nuestra suite funcional audita 32 casos de prueba críticos que abarcan desde el registro transaccional de órdenes con bloqueo de existencias hasta la generación de comprobantes PDF y la navegación en el cliente. El 100% de los casos de prueba ejecutados resultaron aprobados de forma determinística.</a:t>
+              <a:t/>
             </a:r>
             <a:endParaRPr lang="en-US" dirty="0"/>
           </a:p>
@@ -1870,9 +2677,9 @@
           <a:p>
             <a:r>
               <a:rPr lang="en-US" dirty="0"/>
-              <a:t>Expositor: Víctor Leandro Cárdenas Fernández (Product Owner / Backend)
-Tiempo: 45 seg
-Guion: Presentamos el reporte oficial de cobertura generado por el motor Istanbul. Superamos holgadamente los estándares académicos de la industria: alcanzamos un 91.4% en cobertura de líneas de código, un 94.2% en funciones y un 86.5% en ramas condicionales. Esto garantiza que tanto los caminos exitosos como las excepciones y flujos de error han sido auditados mediante aserciones automáticas. Cedo la palabra a Harley Roman para sustentar las pruebas de interoperabilidad y servicios externos.</a:t>
+              <a:t>Expositor: Víctor Leandro Cárdenas Fernández (Product Owner / DBA)
+Tiempo: 50 seg
+Guion: La arquitectura está desacoplada: una PWA estática en el cliente, una API REST en Node.js y una base de datos PostgreSQL. El backend sigue Clean Architecture, separando controladores, casos de uso y repositorios, de modo que la lógica de negocio no depende del framework ni de la base de datos.</a:t>
             </a:r>
             <a:endParaRPr lang="en-US" dirty="0"/>
           </a:p>
@@ -1960,9 +2767,9 @@
           <a:p>
             <a:r>
               <a:rPr lang="en-US" dirty="0"/>
-              <a:t>Expositor: Harley Anthony Roman Delgado (Front-End Lead)
-Tiempo: 10 seg
-Guion: Pasamos al Bloque 3 para defender el Criterio 2 de la rúbrica, detallando la interoperabilidad con sistemas externos y su suite de pruebas automatizadas.</a:t>
+              <a:t>Expositor: Víctor Leandro Cárdenas Fernández (Product Owner / DBA)
+Tiempo: 40 seg
+Guion: El stack es TypeScript de punta a punta. React 19 con Vite en el cliente, Express con Zod en el servidor para validar cada contrato, y PostgreSQL 16 como fuente transaccional. Las pruebas con Jest y Vitest y los pipelines de GitHub Actions cierran el ciclo de calidad.</a:t>
             </a:r>
             <a:endParaRPr lang="en-US" dirty="0"/>
           </a:p>
@@ -2050,9 +2857,9 @@
           <a:p>
             <a:r>
               <a:rPr lang="en-US" dirty="0"/>
-              <a:t>Expositor: Harley Anthony Roman Delgado (Front-End Lead)
-Tiempo: 50 seg
-Guion: Saludos cordiales al honorable jurado. En el Criterio 2 sustentamos la interoperabilidad del sistema con servicios externos. El núcleo de nuestra solución enlaza la PWA con la API de WhatsApp para disparar la confirmación instantánea del pedido al cliente. Asimismo, el sistema implementa integración con pasarelas de pago móvil y validadores de identidad fiscal de DNI y RUC, complementado con la emisión de rótulos con código QR para las agencias de transporte interprovincial.</a:t>
+              <a:t>Expositor: Víctor Leandro Cárdenas Fernández (Product Owner / DBA)
+Tiempo: 55 seg
+Guion: El problema técnico central es que dos clientes no pueden comprar la última unidad al mismo tiempo. Lo resolvimos en la base de datos: un trigger descuenta el stock de forma atómica y las transacciones usan bloqueo pesimista con reintentos ante deadlocks. El modelo está normalizado hasta BCNF y el pedido sigue una máquina de estados finita. Cedo la palabra a Lady Loayza para la seguridad.</a:t>
             </a:r>
             <a:endParaRPr lang="en-US" dirty="0"/>
           </a:p>
@@ -2140,9 +2947,9 @@
           <a:p>
             <a:r>
               <a:rPr lang="en-US" dirty="0"/>
-              <a:t>Expositor: Harley Anthony Roman Delgado (Front-End Lead)
+              <a:t>Expositor: Lady Luz Loayza Rodriguez (Scrum Master / DevSecOps)
 Tiempo: 50 seg
-Guion: Diseñamos una suite de pruebas de integración con siete escenarios automatizados en integration_external.test.ts. Validamos el envío exitoso hacia el gateway de WhatsApp en 27 milisegundos, el rechazo de números inválidos, la conciliación de webhooks de pago y el filtrado estricto de documentos tributarios. Todas las pruebas de interoperabilidad se ejecutaron con éxito y latencias inferiores a 30 milisegundos. Doy el pase a Jim Dávila para sustentar la evaluación de usabilidad según la norma ISO 25010.</a:t>
+Guion: La seguridad se aplicó desde el diseño. Roles con control de acceso, contraseñas con bcrypt y mitigación de ataques de tiempo, tokens JWT que rechazan el algoritmo none y una API que se niega a arrancar sin sus secretos. Los webhooks de pago se verifican con HMAC y comparación en tiempo constante. Todo esto está cubierto por pruebas automatizadas.</a:t>
             </a:r>
             <a:endParaRPr lang="en-US" dirty="0"/>
           </a:p>
@@ -2923,6 +3730,357 @@
 <file path=ppt/slides/slide2.xml><?xml version="1.0" encoding="utf-8"?>
 <p:sld xmlns:a="http://schemas.openxmlformats.org/drawingml/2006/main" xmlns:r="http://schemas.openxmlformats.org/officeDocument/2006/relationships" xmlns:p="http://schemas.openxmlformats.org/presentationml/2006/main">
   <p:cSld name="Slide 2">
+    <p:bg>
+      <p:bgPr>
+        <a:blipFill dpi="0" rotWithShape="1">
+          <a:blip r:embed="rId1">
+            <a:lum/>
+          </a:blip>
+          <a:srcRect/>
+          <a:stretch>
+            <a:fillRect/>
+          </a:stretch>
+        </a:blipFill>
+        <a:effectLst/>
+      </p:bgPr>
+    </p:bg>
+    <p:spTree>
+      <p:nvGrpSpPr>
+        <p:cNvPr id="1" name=""/>
+        <p:cNvGrpSpPr/>
+        <p:nvPr/>
+      </p:nvGrpSpPr>
+      <p:grpSpPr>
+        <a:xfrm>
+          <a:off x="0" y="0"/>
+          <a:ext cx="0" cy="0"/>
+          <a:chOff x="0" y="0"/>
+          <a:chExt cx="0" cy="0"/>
+        </a:xfrm>
+      </p:grpSpPr>
+    </p:spTree>
+  </p:cSld>
+  <p:clrMapOvr>
+    <a:masterClrMapping/>
+  </p:clrMapOvr>
+</p:sld>
+</file>
+
+<file path=ppt/slides/slide20.xml><?xml version="1.0" encoding="utf-8"?>
+<p:sld xmlns:a="http://schemas.openxmlformats.org/drawingml/2006/main" xmlns:r="http://schemas.openxmlformats.org/officeDocument/2006/relationships" xmlns:p="http://schemas.openxmlformats.org/presentationml/2006/main">
+  <p:cSld name="Slide 20">
+    <p:bg>
+      <p:bgPr>
+        <a:blipFill dpi="0" rotWithShape="1">
+          <a:blip r:embed="rId1">
+            <a:lum/>
+          </a:blip>
+          <a:srcRect/>
+          <a:stretch>
+            <a:fillRect/>
+          </a:stretch>
+        </a:blipFill>
+        <a:effectLst/>
+      </p:bgPr>
+    </p:bg>
+    <p:spTree>
+      <p:nvGrpSpPr>
+        <p:cNvPr id="1" name=""/>
+        <p:cNvGrpSpPr/>
+        <p:nvPr/>
+      </p:nvGrpSpPr>
+      <p:grpSpPr>
+        <a:xfrm>
+          <a:off x="0" y="0"/>
+          <a:ext cx="0" cy="0"/>
+          <a:chOff x="0" y="0"/>
+          <a:chExt cx="0" cy="0"/>
+        </a:xfrm>
+      </p:grpSpPr>
+    </p:spTree>
+  </p:cSld>
+  <p:clrMapOvr>
+    <a:masterClrMapping/>
+  </p:clrMapOvr>
+</p:sld>
+</file>
+
+<file path=ppt/slides/slide21.xml><?xml version="1.0" encoding="utf-8"?>
+<p:sld xmlns:a="http://schemas.openxmlformats.org/drawingml/2006/main" xmlns:r="http://schemas.openxmlformats.org/officeDocument/2006/relationships" xmlns:p="http://schemas.openxmlformats.org/presentationml/2006/main">
+  <p:cSld name="Slide 21">
+    <p:bg>
+      <p:bgPr>
+        <a:blipFill dpi="0" rotWithShape="1">
+          <a:blip r:embed="rId1">
+            <a:lum/>
+          </a:blip>
+          <a:srcRect/>
+          <a:stretch>
+            <a:fillRect/>
+          </a:stretch>
+        </a:blipFill>
+        <a:effectLst/>
+      </p:bgPr>
+    </p:bg>
+    <p:spTree>
+      <p:nvGrpSpPr>
+        <p:cNvPr id="1" name=""/>
+        <p:cNvGrpSpPr/>
+        <p:nvPr/>
+      </p:nvGrpSpPr>
+      <p:grpSpPr>
+        <a:xfrm>
+          <a:off x="0" y="0"/>
+          <a:ext cx="0" cy="0"/>
+          <a:chOff x="0" y="0"/>
+          <a:chExt cx="0" cy="0"/>
+        </a:xfrm>
+      </p:grpSpPr>
+    </p:spTree>
+  </p:cSld>
+  <p:clrMapOvr>
+    <a:masterClrMapping/>
+  </p:clrMapOvr>
+</p:sld>
+</file>
+
+<file path=ppt/slides/slide22.xml><?xml version="1.0" encoding="utf-8"?>
+<p:sld xmlns:a="http://schemas.openxmlformats.org/drawingml/2006/main" xmlns:r="http://schemas.openxmlformats.org/officeDocument/2006/relationships" xmlns:p="http://schemas.openxmlformats.org/presentationml/2006/main">
+  <p:cSld name="Slide 22">
+    <p:bg>
+      <p:bgPr>
+        <a:blipFill dpi="0" rotWithShape="1">
+          <a:blip r:embed="rId1">
+            <a:lum/>
+          </a:blip>
+          <a:srcRect/>
+          <a:stretch>
+            <a:fillRect/>
+          </a:stretch>
+        </a:blipFill>
+        <a:effectLst/>
+      </p:bgPr>
+    </p:bg>
+    <p:spTree>
+      <p:nvGrpSpPr>
+        <p:cNvPr id="1" name=""/>
+        <p:cNvGrpSpPr/>
+        <p:nvPr/>
+      </p:nvGrpSpPr>
+      <p:grpSpPr>
+        <a:xfrm>
+          <a:off x="0" y="0"/>
+          <a:ext cx="0" cy="0"/>
+          <a:chOff x="0" y="0"/>
+          <a:chExt cx="0" cy="0"/>
+        </a:xfrm>
+      </p:grpSpPr>
+    </p:spTree>
+  </p:cSld>
+  <p:clrMapOvr>
+    <a:masterClrMapping/>
+  </p:clrMapOvr>
+</p:sld>
+</file>
+
+<file path=ppt/slides/slide23.xml><?xml version="1.0" encoding="utf-8"?>
+<p:sld xmlns:a="http://schemas.openxmlformats.org/drawingml/2006/main" xmlns:r="http://schemas.openxmlformats.org/officeDocument/2006/relationships" xmlns:p="http://schemas.openxmlformats.org/presentationml/2006/main">
+  <p:cSld name="Slide 23">
+    <p:bg>
+      <p:bgPr>
+        <a:blipFill dpi="0" rotWithShape="1">
+          <a:blip r:embed="rId1">
+            <a:lum/>
+          </a:blip>
+          <a:srcRect/>
+          <a:stretch>
+            <a:fillRect/>
+          </a:stretch>
+        </a:blipFill>
+        <a:effectLst/>
+      </p:bgPr>
+    </p:bg>
+    <p:spTree>
+      <p:nvGrpSpPr>
+        <p:cNvPr id="1" name=""/>
+        <p:cNvGrpSpPr/>
+        <p:nvPr/>
+      </p:nvGrpSpPr>
+      <p:grpSpPr>
+        <a:xfrm>
+          <a:off x="0" y="0"/>
+          <a:ext cx="0" cy="0"/>
+          <a:chOff x="0" y="0"/>
+          <a:chExt cx="0" cy="0"/>
+        </a:xfrm>
+      </p:grpSpPr>
+    </p:spTree>
+  </p:cSld>
+  <p:clrMapOvr>
+    <a:masterClrMapping/>
+  </p:clrMapOvr>
+</p:sld>
+</file>
+
+<file path=ppt/slides/slide24.xml><?xml version="1.0" encoding="utf-8"?>
+<p:sld xmlns:a="http://schemas.openxmlformats.org/drawingml/2006/main" xmlns:r="http://schemas.openxmlformats.org/officeDocument/2006/relationships" xmlns:p="http://schemas.openxmlformats.org/presentationml/2006/main">
+  <p:cSld name="Slide 24">
+    <p:bg>
+      <p:bgPr>
+        <a:blipFill dpi="0" rotWithShape="1">
+          <a:blip r:embed="rId1">
+            <a:lum/>
+          </a:blip>
+          <a:srcRect/>
+          <a:stretch>
+            <a:fillRect/>
+          </a:stretch>
+        </a:blipFill>
+        <a:effectLst/>
+      </p:bgPr>
+    </p:bg>
+    <p:spTree>
+      <p:nvGrpSpPr>
+        <p:cNvPr id="1" name=""/>
+        <p:cNvGrpSpPr/>
+        <p:nvPr/>
+      </p:nvGrpSpPr>
+      <p:grpSpPr>
+        <a:xfrm>
+          <a:off x="0" y="0"/>
+          <a:ext cx="0" cy="0"/>
+          <a:chOff x="0" y="0"/>
+          <a:chExt cx="0" cy="0"/>
+        </a:xfrm>
+      </p:grpSpPr>
+    </p:spTree>
+  </p:cSld>
+  <p:clrMapOvr>
+    <a:masterClrMapping/>
+  </p:clrMapOvr>
+</p:sld>
+</file>
+
+<file path=ppt/slides/slide25.xml><?xml version="1.0" encoding="utf-8"?>
+<p:sld xmlns:a="http://schemas.openxmlformats.org/drawingml/2006/main" xmlns:r="http://schemas.openxmlformats.org/officeDocument/2006/relationships" xmlns:p="http://schemas.openxmlformats.org/presentationml/2006/main">
+  <p:cSld name="Slide 25">
+    <p:bg>
+      <p:bgPr>
+        <a:blipFill dpi="0" rotWithShape="1">
+          <a:blip r:embed="rId1">
+            <a:lum/>
+          </a:blip>
+          <a:srcRect/>
+          <a:stretch>
+            <a:fillRect/>
+          </a:stretch>
+        </a:blipFill>
+        <a:effectLst/>
+      </p:bgPr>
+    </p:bg>
+    <p:spTree>
+      <p:nvGrpSpPr>
+        <p:cNvPr id="1" name=""/>
+        <p:cNvGrpSpPr/>
+        <p:nvPr/>
+      </p:nvGrpSpPr>
+      <p:grpSpPr>
+        <a:xfrm>
+          <a:off x="0" y="0"/>
+          <a:ext cx="0" cy="0"/>
+          <a:chOff x="0" y="0"/>
+          <a:chExt cx="0" cy="0"/>
+        </a:xfrm>
+      </p:grpSpPr>
+    </p:spTree>
+  </p:cSld>
+  <p:clrMapOvr>
+    <a:masterClrMapping/>
+  </p:clrMapOvr>
+</p:sld>
+</file>
+
+<file path=ppt/slides/slide26.xml><?xml version="1.0" encoding="utf-8"?>
+<p:sld xmlns:a="http://schemas.openxmlformats.org/drawingml/2006/main" xmlns:r="http://schemas.openxmlformats.org/officeDocument/2006/relationships" xmlns:p="http://schemas.openxmlformats.org/presentationml/2006/main">
+  <p:cSld name="Slide 26">
+    <p:bg>
+      <p:bgPr>
+        <a:blipFill dpi="0" rotWithShape="1">
+          <a:blip r:embed="rId1">
+            <a:lum/>
+          </a:blip>
+          <a:srcRect/>
+          <a:stretch>
+            <a:fillRect/>
+          </a:stretch>
+        </a:blipFill>
+        <a:effectLst/>
+      </p:bgPr>
+    </p:bg>
+    <p:spTree>
+      <p:nvGrpSpPr>
+        <p:cNvPr id="1" name=""/>
+        <p:cNvGrpSpPr/>
+        <p:nvPr/>
+      </p:nvGrpSpPr>
+      <p:grpSpPr>
+        <a:xfrm>
+          <a:off x="0" y="0"/>
+          <a:ext cx="0" cy="0"/>
+          <a:chOff x="0" y="0"/>
+          <a:chExt cx="0" cy="0"/>
+        </a:xfrm>
+      </p:grpSpPr>
+    </p:spTree>
+  </p:cSld>
+  <p:clrMapOvr>
+    <a:masterClrMapping/>
+  </p:clrMapOvr>
+</p:sld>
+</file>
+
+<file path=ppt/slides/slide27.xml><?xml version="1.0" encoding="utf-8"?>
+<p:sld xmlns:a="http://schemas.openxmlformats.org/drawingml/2006/main" xmlns:r="http://schemas.openxmlformats.org/officeDocument/2006/relationships" xmlns:p="http://schemas.openxmlformats.org/presentationml/2006/main">
+  <p:cSld name="Slide 27">
+    <p:bg>
+      <p:bgPr>
+        <a:blipFill dpi="0" rotWithShape="1">
+          <a:blip r:embed="rId1">
+            <a:lum/>
+          </a:blip>
+          <a:srcRect/>
+          <a:stretch>
+            <a:fillRect/>
+          </a:stretch>
+        </a:blipFill>
+        <a:effectLst/>
+      </p:bgPr>
+    </p:bg>
+    <p:spTree>
+      <p:nvGrpSpPr>
+        <p:cNvPr id="1" name=""/>
+        <p:cNvGrpSpPr/>
+        <p:nvPr/>
+      </p:nvGrpSpPr>
+      <p:grpSpPr>
+        <a:xfrm>
+          <a:off x="0" y="0"/>
+          <a:ext cx="0" cy="0"/>
+          <a:chOff x="0" y="0"/>
+          <a:chExt cx="0" cy="0"/>
+        </a:xfrm>
+      </p:grpSpPr>
+    </p:spTree>
+  </p:cSld>
+  <p:clrMapOvr>
+    <a:masterClrMapping/>
+  </p:clrMapOvr>
+</p:sld>
+</file>
+
+<file path=ppt/slides/slide28.xml><?xml version="1.0" encoding="utf-8"?>
+<p:sld xmlns:a="http://schemas.openxmlformats.org/drawingml/2006/main" xmlns:r="http://schemas.openxmlformats.org/officeDocument/2006/relationships" xmlns:p="http://schemas.openxmlformats.org/presentationml/2006/main">
+  <p:cSld name="Slide 28">
     <p:bg>
       <p:bgPr>
         <a:blipFill dpi="0" rotWithShape="1">

</xml_diff>